<commit_message>
Deck demo slide with the official create example (llama3.1 8B run); submission package text
Co-Authored-By: Claude Opus 5.5 <noreply@anthropic.com>
Claude-Session: https://claude.ai/code/session_01MuMSSbQiPDoHjWpX9fweWU
</commit_message>
<xml_diff>
--- a/docs/pitch/Hyperion-Steward-VelesHack.pptx
+++ b/docs/pitch/Hyperion-Steward-VelesHack.pptx
@@ -5800,7 +5800,7 @@
                   <a:srgbClr val="212121"/>
                 </a:solidFill>
               </a:rPr>
-              <a:t>docker run -p 8000:8000 --add-host host.docker.internal:host-gateway -e API_KEY=&lt;team key&gt; &lt;dockerhub-user&gt;/hyperion:latest</a:t>
+              <a:t>docker run -p 8000:8000 --add-host host.docker.internal:host-gateway -e API_KEY=&lt;key&gt; &lt;dockerhub-user&gt;/hyperion:latest</a:t>
             </a:r>
           </a:p>
           <a:p>
@@ -8385,7 +8385,7 @@
       </p:sp>
       <p:pic>
         <p:nvPicPr>
-          <p:cNvPr id="3" name="ide-screenshot" descr="02-check-native.png"/>
+          <p:cNvPr id="3" name="ide-screenshot" descr="demo.png"/>
           <p:cNvPicPr>
             <a:picLocks noChangeAspect="1"/>
           </p:cNvPicPr>
@@ -8531,6 +8531,31 @@
                 <a:latin typeface="Arial"/>
               </a:rPr>
               <a:t>each change is read back before Steward says it happened.</a:t>
+            </a:r>
+          </a:p>
+          <a:p>
+            <a:pPr algn="l">
+              <a:spcAft>
+                <a:spcPts val="400"/>
+              </a:spcAft>
+            </a:pPr>
+            <a:r>
+              <a:rPr sz="1200" b="1">
+                <a:solidFill>
+                  <a:srgbClr val="1F2A6B"/>
+                </a:solidFill>
+                <a:latin typeface="Arial"/>
+              </a:rPr>
+              <a:t>Shown: </a:t>
+            </a:r>
+            <a:r>
+              <a:rPr sz="1200" b="0">
+                <a:solidFill>
+                  <a:srgbClr val="595959"/>
+                </a:solidFill>
+                <a:latin typeface="Arial"/>
+              </a:rPr>
+              <a:t>the official create example, file opened in the editor. CI run with llama3.1 8B, 7/7.</a:t>
             </a:r>
           </a:p>
         </p:txBody>
@@ -9192,7 +9217,7 @@
                 </a:solidFill>
                 <a:latin typeface="Arial"/>
               </a:rPr>
-              <a:t>Open models (qwen2.5 3B/7B) driving the full stack in CI</a:t>
+              <a:t>llama3.1 8B (the model family the organisers serve) in the official GUI, CI</a:t>
             </a:r>
           </a:p>
         </p:txBody>
@@ -9293,7 +9318,7 @@
                 </a:solidFill>
                 <a:latin typeface="Arial"/>
               </a:rPr>
-              <a:t>Runs on the organisers' server (legion1): needs the team key</a:t>
+              <a:t>Answer quality on the organisers' server (legion1) not measured before submission</a:t>
             </a:r>
           </a:p>
           <a:p>

</xml_diff>

<commit_message>
Evaluation image faadil12/hyperion:latest everywhere; revision label on images; published-image workflow: clean pull + official IDE + browser, with and without a model (D-034)
Co-Authored-By: Claude Opus 5.5 <noreply@anthropic.com>
Claude-Session: https://claude.ai/code/session_01MuMSSbQiPDoHjWpX9fweWU
</commit_message>
<xml_diff>
--- a/docs/pitch/Hyperion-Steward-VelesHack.pptx
+++ b/docs/pitch/Hyperion-Steward-VelesHack.pptx
@@ -5777,7 +5777,7 @@
                   <a:srgbClr val="212121"/>
                 </a:solidFill>
               </a:rPr>
-              <a:t>&lt;dockerhub-user&gt;/hyperion:latest  (exposes :8000/chat)</a:t>
+              <a:t>faadil12/hyperion:latest  (exposes :8000/chat)</a:t>
             </a:r>
           </a:p>
           <a:p>
@@ -5800,7 +5800,7 @@
                   <a:srgbClr val="212121"/>
                 </a:solidFill>
               </a:rPr>
-              <a:t>docker run -p 8000:8000 --add-host host.docker.internal:host-gateway -e API_KEY=&lt;key&gt; &lt;dockerhub-user&gt;/hyperion:latest</a:t>
+              <a:t>docker run -p 8000:8000 --add-host host.docker.internal:host-gateway -e API_KEY=&lt;key&gt; faadil12/hyperion:latest</a:t>
             </a:r>
           </a:p>
           <a:p>

</xml_diff>

<commit_message>
Final Canonical Assurance SUBMISSION_READY with independent cross-check; README/SUBMISSION/deck labels; handover and state (D-038)
Co-Authored-By: Claude Opus 5.5 <noreply@anthropic.com>
Claude-Session: https://claude.ai/code/session_01MuMSSbQiPDoHjWpX9fweWU
</commit_message>
<xml_diff>
--- a/docs/pitch/Hyperion-Steward-VelesHack.pptx
+++ b/docs/pitch/Hyperion-Steward-VelesHack.pptx
@@ -6548,7 +6548,7 @@
                 </a:solidFill>
                 <a:latin typeface="Arial"/>
               </a:rPr>
-              <a:t>safety scenarios handled correctly. Naive agent: 1/9</a:t>
+              <a:t>safety scenarios handled correctly (same tool calls, stub mirroring the IDE). Naive agent: 1/9</a:t>
             </a:r>
           </a:p>
         </p:txBody>
@@ -6672,7 +6672,7 @@
                 </a:solidFill>
                 <a:latin typeface="Arial"/>
               </a:rPr>
-              <a:t>false "done" claims. Naive agent: 5</a:t>
+              <a:t>false "done" claims in the same scenarios. Naive agent: 5</a:t>
             </a:r>
           </a:p>
         </p:txBody>

</xml_diff>

<commit_message>
Final truth-boundary reconciliation: exact confirmation/undo wording, ablation labelled LOCAL_STUB in the pitch, clean pull recorded in the ledger, state and handover final (D-039); deck rebuilt; runtime untouched
Co-Authored-By: Claude Opus 5.5 <noreply@anthropic.com>
Claude-Session: https://claude.ai/code/session_01MuMSSbQiPDoHjWpX9fweWU
</commit_message>
<xml_diff>
--- a/docs/pitch/Hyperion-Steward-VelesHack.pptx
+++ b/docs/pitch/Hyperion-Steward-VelesHack.pptx
@@ -6054,7 +6054,7 @@
                   <a:srgbClr val="212121"/>
                 </a:solidFill>
               </a:rPr>
-              <a:t>Steward checks every profile with an exact copy of the IDE validator, then reads the workspace back and only claims what it saw. Confirmation, restore points and undo for every change.</a:t>
+              <a:t>Steward checks every profile with an exact copy of the IDE validator, then reads the workspace back and only claims what it saw. Deletes always ask; overwrites ask unless you named the file or Steward created it; file changes can be undone (a folder delete cannot).</a:t>
             </a:r>
           </a:p>
         </p:txBody>
@@ -8997,7 +8997,7 @@
                           </a:solidFill>
                           <a:latin typeface="Arial"/>
                         </a:rPr>
-                        <a:t>Confirm delete and overwrite; restore points; undo</a:t>
+                        <a:t>Deletes always confirmed; overwrites unless path named or self-created; undo for file changes</a:t>
                       </a:r>
                     </a:p>
                   </a:txBody>

</xml_diff>